<commit_message>
PPT Formatting revisions+new pdf
</commit_message>
<xml_diff>
--- a/deck/51001_DataBaes_ProblemStatementID.pptx
+++ b/deck/51001_DataBaes_ProblemStatementID.pptx
@@ -22,7 +22,7 @@
       <p:regular r:id="rId8"/>
     </p:embeddedFont>
     <p:embeddedFont>
-      <p:font typeface="Roboto Mono" panose="020F0502020204030204" charset="0"/>
+      <p:font typeface="Roboto Mono" panose="00000009000000000000" pitchFamily="49" charset="0"/>
       <p:regular r:id="rId9"/>
       <p:bold r:id="rId10"/>
       <p:italic r:id="rId11"/>
@@ -747,8 +747,8 @@
         </p:nvSpPr>
         <p:spPr>
           <a:xfrm>
-            <a:off x="381300" y="685800"/>
-            <a:ext cx="6096075" cy="3429000"/>
+            <a:off x="381000" y="685800"/>
+            <a:ext cx="6096000" cy="3429000"/>
           </a:xfrm>
           <a:custGeom>
             <a:avLst/>
@@ -6087,7 +6087,7 @@
         <p:spPr>
           <a:xfrm>
             <a:off x="112050" y="1683300"/>
-            <a:ext cx="9144000" cy="3065700"/>
+            <a:ext cx="9031950" cy="3065700"/>
           </a:xfrm>
           <a:prstGeom prst="rect">
             <a:avLst/>
@@ -6095,7 +6095,7 @@
         </p:spPr>
         <p:txBody>
           <a:bodyPr spcFirstLastPara="1" wrap="square" lIns="91425" tIns="91425" rIns="91425" bIns="91425" anchor="t" anchorCtr="0">
-            <a:normAutofit/>
+            <a:normAutofit lnSpcReduction="10000"/>
           </a:bodyPr>
           <a:lstStyle/>
           <a:p>
@@ -6109,7 +6109,7 @@
               <a:buNone/>
             </a:pPr>
             <a:r>
-              <a:rPr lang="en-GB" sz="2500">
+              <a:rPr lang="en-GB" sz="2500" dirty="0">
                 <a:solidFill>
                   <a:schemeClr val="dk1"/>
                 </a:solidFill>
@@ -6118,9 +6118,21 @@
                 <a:cs typeface="Roboto Mono"/>
                 <a:sym typeface="Roboto Mono"/>
               </a:rPr>
-              <a:t>Team Name: DataBaes</a:t>
+              <a:t>Team Name: </a:t>
             </a:r>
-            <a:endParaRPr sz="2500">
+            <a:r>
+              <a:rPr lang="en-GB" sz="2500" dirty="0" err="1">
+                <a:solidFill>
+                  <a:schemeClr val="dk1"/>
+                </a:solidFill>
+                <a:latin typeface="Roboto Mono"/>
+                <a:ea typeface="Roboto Mono"/>
+                <a:cs typeface="Roboto Mono"/>
+                <a:sym typeface="Roboto Mono"/>
+              </a:rPr>
+              <a:t>DataBaes</a:t>
+            </a:r>
+            <a:endParaRPr sz="2500" dirty="0">
               <a:solidFill>
                 <a:schemeClr val="dk1"/>
               </a:solidFill>
@@ -6141,7 +6153,7 @@
               <a:buNone/>
             </a:pPr>
             <a:r>
-              <a:rPr lang="en-GB" sz="2500">
+              <a:rPr lang="en-GB" sz="2500" dirty="0">
                 <a:solidFill>
                   <a:schemeClr val="dk1"/>
                 </a:solidFill>
@@ -6152,7 +6164,7 @@
               </a:rPr>
               <a:t>Track: Sustainable Cities and Communities (SDG 11)</a:t>
             </a:r>
-            <a:endParaRPr sz="2500">
+            <a:endParaRPr sz="2500" dirty="0">
               <a:solidFill>
                 <a:schemeClr val="dk1"/>
               </a:solidFill>
@@ -6173,7 +6185,7 @@
               <a:buNone/>
             </a:pPr>
             <a:r>
-              <a:rPr lang="en-GB" sz="2500">
+              <a:rPr lang="en-GB" sz="2500" dirty="0">
                 <a:solidFill>
                   <a:schemeClr val="dk1"/>
                 </a:solidFill>
@@ -6184,7 +6196,7 @@
               </a:rPr>
               <a:t>Problem Statement: Cascading Failure - When One Failure Becomes Many</a:t>
             </a:r>
-            <a:endParaRPr sz="2500">
+            <a:endParaRPr sz="2500" dirty="0">
               <a:solidFill>
                 <a:schemeClr val="dk1"/>
               </a:solidFill>
@@ -6205,7 +6217,7 @@
               <a:buNone/>
             </a:pPr>
             <a:r>
-              <a:rPr lang="en-GB" sz="2500">
+              <a:rPr lang="en-GB" sz="2500" dirty="0">
                 <a:solidFill>
                   <a:schemeClr val="dk1"/>
                 </a:solidFill>
@@ -6216,7 +6228,7 @@
               </a:rPr>
               <a:t>Solution Title: Ripple</a:t>
             </a:r>
-            <a:endParaRPr sz="2500">
+            <a:endParaRPr sz="2500" dirty="0">
               <a:solidFill>
                 <a:schemeClr val="dk1"/>
               </a:solidFill>
@@ -6242,7 +6254,7 @@
               <a:buNone/>
             </a:pPr>
             <a:r>
-              <a:rPr lang="en-GB" sz="2500">
+              <a:rPr lang="en-GB" sz="2500" dirty="0">
                 <a:solidFill>
                   <a:schemeClr val="dk1"/>
                 </a:solidFill>
@@ -6251,9 +6263,33 @@
                 <a:cs typeface="Roboto Mono"/>
                 <a:sym typeface="Roboto Mono"/>
               </a:rPr>
-              <a:t>Team Members: Sagnik Basu, Man Mohit Kumar, Yashaswi Mohan, Pagavath D P, Amritanshu</a:t>
+              <a:t>Team Members: Sagnik Basu, Man Mohit Kumar, Yashaswi Mohan, </a:t>
             </a:r>
-            <a:endParaRPr sz="2500">
+            <a:r>
+              <a:rPr lang="en-GB" sz="2500" dirty="0" err="1">
+                <a:solidFill>
+                  <a:schemeClr val="dk1"/>
+                </a:solidFill>
+                <a:latin typeface="Roboto Mono"/>
+                <a:ea typeface="Roboto Mono"/>
+                <a:cs typeface="Roboto Mono"/>
+                <a:sym typeface="Roboto Mono"/>
+              </a:rPr>
+              <a:t>Pagavath</a:t>
+            </a:r>
+            <a:r>
+              <a:rPr lang="en-GB" sz="2500" dirty="0">
+                <a:solidFill>
+                  <a:schemeClr val="dk1"/>
+                </a:solidFill>
+                <a:latin typeface="Roboto Mono"/>
+                <a:ea typeface="Roboto Mono"/>
+                <a:cs typeface="Roboto Mono"/>
+                <a:sym typeface="Roboto Mono"/>
+              </a:rPr>
+              <a:t> D P, Amritanshu</a:t>
+            </a:r>
+            <a:endParaRPr sz="2500" dirty="0">
               <a:solidFill>
                 <a:schemeClr val="dk1"/>
               </a:solidFill>
@@ -6273,7 +6309,7 @@
               </a:spcAft>
               <a:buNone/>
             </a:pPr>
-            <a:endParaRPr/>
+            <a:endParaRPr dirty="0"/>
           </a:p>
           <a:p>
             <a:pPr marL="0" lvl="0" indent="0" algn="ctr" rtl="0">
@@ -6285,7 +6321,7 @@
               </a:spcAft>
               <a:buNone/>
             </a:pPr>
-            <a:endParaRPr/>
+            <a:endParaRPr dirty="0"/>
           </a:p>
         </p:txBody>
       </p:sp>
@@ -6474,7 +6510,7 @@
         <p:spPr>
           <a:xfrm>
             <a:off x="384048" y="1517904"/>
-            <a:ext cx="8375904" cy="329184"/>
+            <a:ext cx="8375904" cy="218137"/>
           </a:xfrm>
           <a:prstGeom prst="rect">
             <a:avLst/>
@@ -6493,7 +6529,7 @@
               </a:lnSpc>
             </a:pPr>
             <a:r>
-              <a:rPr sz="1450" b="1" i="1">
+              <a:rPr sz="1450" b="1">
                 <a:solidFill>
                   <a:srgbClr val="351C75"/>
                 </a:solidFill>
@@ -7085,7 +7121,7 @@
         </p:nvSpPr>
         <p:spPr>
           <a:xfrm>
-            <a:off x="384048" y="3182112"/>
+            <a:off x="384048" y="3151260"/>
             <a:ext cx="8375904" cy="1737360"/>
           </a:xfrm>
           <a:prstGeom prst="roundRect">
@@ -7209,7 +7245,7 @@
         </p:nvSpPr>
         <p:spPr>
           <a:xfrm>
-            <a:off x="3593592" y="4005072"/>
+            <a:off x="3558540" y="4019940"/>
             <a:ext cx="5001768" cy="566928"/>
           </a:xfrm>
           <a:prstGeom prst="rect">
@@ -7229,7 +7265,7 @@
               </a:lnSpc>
             </a:pPr>
             <a:r>
-              <a:rPr sz="1000" b="0" i="0">
+              <a:rPr sz="1000" b="0" i="0" dirty="0">
                 <a:solidFill>
                   <a:srgbClr val="5B5763"/>
                 </a:solidFill>
@@ -7248,8 +7284,8 @@
         </p:nvSpPr>
         <p:spPr>
           <a:xfrm>
-            <a:off x="3593592" y="4572000"/>
-            <a:ext cx="5001768" cy="310896"/>
+            <a:off x="3331464" y="4539420"/>
+            <a:ext cx="4645375" cy="310896"/>
           </a:xfrm>
           <a:prstGeom prst="roundRect">
             <a:avLst>
@@ -7295,8 +7331,8 @@
         </p:nvSpPr>
         <p:spPr>
           <a:xfrm>
-            <a:off x="4270248" y="4594860"/>
-            <a:ext cx="4727448" cy="228600"/>
+            <a:off x="3917795" y="4539420"/>
+            <a:ext cx="3739376" cy="153888"/>
           </a:xfrm>
           <a:prstGeom prst="rect">
             <a:avLst/>
@@ -7315,7 +7351,7 @@
               </a:lnSpc>
             </a:pPr>
             <a:r>
-              <a:rPr sz="900" b="1" i="1" dirty="0">
+              <a:rPr sz="1000" b="1" dirty="0">
                 <a:solidFill>
                   <a:srgbClr val="1E8E5A"/>
                 </a:solidFill>
@@ -7386,7 +7422,7 @@
               <a:buNone/>
             </a:pPr>
             <a:r>
-              <a:rPr lang="en-GB">
+              <a:rPr lang="en-GB" dirty="0">
                 <a:solidFill>
                   <a:srgbClr val="351C75"/>
                 </a:solidFill>
@@ -7397,7 +7433,7 @@
               </a:rPr>
               <a:t>Technical Implementation</a:t>
             </a:r>
-            <a:endParaRPr>
+            <a:endParaRPr dirty="0">
               <a:solidFill>
                 <a:srgbClr val="351C75"/>
               </a:solidFill>
@@ -9008,7 +9044,7 @@
         <p:spPr>
           <a:xfrm>
             <a:off x="384048" y="4590288"/>
-            <a:ext cx="8375904" cy="274320"/>
+            <a:ext cx="8375904" cy="127856"/>
           </a:xfrm>
           <a:prstGeom prst="rect">
             <a:avLst/>
@@ -9027,7 +9063,7 @@
               </a:lnSpc>
             </a:pPr>
             <a:r>
-              <a:rPr sz="850" b="0" i="1">
+              <a:rPr sz="850" b="0" dirty="0">
                 <a:solidFill>
                   <a:srgbClr val="C4453A"/>
                 </a:solidFill>
@@ -10707,7 +10743,7 @@
               </a:lnSpc>
             </a:pPr>
             <a:r>
-              <a:rPr sz="930" b="0" i="0">
+              <a:rPr sz="930" b="0" i="0" dirty="0">
                 <a:solidFill>
                   <a:srgbClr val="5B5763"/>
                 </a:solidFill>
@@ -10723,7 +10759,7 @@
               </a:lnSpc>
             </a:pPr>
             <a:r>
-              <a:rPr sz="930" b="0" i="0">
+              <a:rPr sz="930" b="0" i="0" dirty="0">
                 <a:solidFill>
                   <a:srgbClr val="5B5763"/>
                 </a:solidFill>
@@ -10739,7 +10775,7 @@
               </a:lnSpc>
             </a:pPr>
             <a:r>
-              <a:rPr sz="930" b="0" i="0">
+              <a:rPr sz="930" b="0" i="0" dirty="0">
                 <a:solidFill>
                   <a:srgbClr val="5B5763"/>
                 </a:solidFill>
@@ -10805,7 +10841,7 @@
         </p:nvSpPr>
         <p:spPr>
           <a:xfrm>
-            <a:off x="530352" y="3273552"/>
+            <a:off x="530352" y="3182112"/>
             <a:ext cx="292608" cy="292608"/>
           </a:xfrm>
           <a:prstGeom prst="ellipse">
@@ -10839,7 +10875,7 @@
           <a:p>
             <a:pPr algn="ctr"/>
             <a:r>
-              <a:rPr sz="1100" b="1">
+              <a:rPr sz="1100" b="1" dirty="0">
                 <a:solidFill>
                   <a:srgbClr val="FFFFFF"/>
                 </a:solidFill>
@@ -10983,7 +11019,7 @@
         </p:nvSpPr>
         <p:spPr>
           <a:xfrm>
-            <a:off x="3351276" y="3273552"/>
+            <a:off x="3351276" y="3182112"/>
             <a:ext cx="292608" cy="292608"/>
           </a:xfrm>
           <a:prstGeom prst="ellipse">
@@ -11017,7 +11053,7 @@
           <a:p>
             <a:pPr algn="ctr"/>
             <a:r>
-              <a:rPr sz="1100" b="1">
+              <a:rPr sz="1100" b="1" dirty="0">
                 <a:solidFill>
                   <a:srgbClr val="FFFFFF"/>
                 </a:solidFill>
@@ -11161,7 +11197,7 @@
         </p:nvSpPr>
         <p:spPr>
           <a:xfrm>
-            <a:off x="6172200" y="3273552"/>
+            <a:off x="6172200" y="3182112"/>
             <a:ext cx="292608" cy="292608"/>
           </a:xfrm>
           <a:prstGeom prst="ellipse">

</xml_diff>